<commit_message>
Rename all model checkpoints by role and update evaluation paths
</commit_message>
<xml_diff>
--- a/submission/Ant_Unseen_Terrain_5min.pptx
+++ b/submission/Ant_Unseen_Terrain_5min.pptx
@@ -788,7 +788,7 @@
           <a:lstStyle/>
           <a:p>
             <a:r>
-              <a:t>두 모델 모두 E3-SpawnLift, seed 24, 100개 환경, 원본 보상으로 비교했습니다. 기존 Failure2의 평균 보상은 73.75, 최종 모델은 81.90입니다. 생존율은 82%에서 88%, 전진 거리는 78.66미터에서 82.79미터로 증가했습니다. 에피소드 길이도 늘었습니다. 이 결과는 실패를 줄여 더 오래 전진하는 방향과 일치하지만, 한 학습 seed의 관찰이므로 인과 효과나 일반적 우위를 확정하지 않습니다. 또 이 결과를 원래 reset 조건의 E3 점수와 합쳐서 개선량을 부풀리지 않았습니다.</a:t>
+              <a:t>두 모델 모두 E3-SpawnLift, seed 24, 100개 환경, 원본 보상으로 비교했습니다. 기존 FailurePenalty의 평균 보상은 73.75, 최종 모델은 81.90입니다. 생존율은 82%에서 88%, 전진 거리는 78.66미터에서 82.79미터로 증가했습니다. 에피소드 길이도 늘었습니다. 이 결과는 실패를 줄여 더 오래 전진하는 방향과 일치하지만, 한 학습 seed의 관찰이므로 인과 효과나 일반적 우위를 확정하지 않습니다. 또 이 결과를 원래 reset 조건의 E3 점수와 합쳐서 개선량을 부풀리지 않았습니다.</a:t>
             </a:r>
           </a:p>
         </p:txBody>
@@ -6107,7 +6107,7 @@
                         </a:defRPr>
                       </a:pPr>
                       <a:r>
-                        <a:t>기존 Failure2</a:t>
+                        <a:t>기존 FailurePenalty</a:t>
                       </a:r>
                     </a:p>
                   </a:txBody>
@@ -6131,7 +6131,7 @@
                         </a:defRPr>
                       </a:pPr>
                       <a:r>
-                        <a:t>최종 Failure2Lift</a:t>
+                        <a:t>최종 Final</a:t>
                       </a:r>
                     </a:p>
                   </a:txBody>

</xml_diff>